<commit_message>
Add AI-assistance disclaimer across all pages and documents
Consistent disclaimer referencing MIA on all three HTML dashboards
(comprehensive-briefing, index, workforce-dynamics) and within all
linked documents (comprehensive Word report, TOCA analysis report,
workforce dynamics report, PowerPoint briefing). Covers AI assistance,
not-investment-advice, public-data-only, and source verification.

Co-Authored-By: Claude Opus 4.6 <noreply@anthropic.com>
</commit_message>
<xml_diff>
--- a/docs/BMO_Workforce_Analytics_Briefing.pptx
+++ b/docs/BMO_Workforce_Analytics_Briefing.pptx
@@ -13644,7 +13644,7 @@
         <p:spPr>
           <a:xfrm>
             <a:off x="640080" y="3931920"/>
-            <a:ext cx="4572000" cy="457200"/>
+            <a:ext cx="7315200" cy="731520"/>
           </a:xfrm>
           <a:prstGeom prst="rect">
             <a:avLst/>
@@ -13658,12 +13658,12 @@
           <a:p>
             <a:pPr indent="0" marL="0">
               <a:lnSpc>
-                <a:spcPct val="130000"/>
+                <a:spcPct val="135000"/>
               </a:lnSpc>
               <a:buNone/>
             </a:pPr>
             <a:r>
-              <a:rPr lang="en-US" sz="900" i="1" dirty="0">
+              <a:rPr lang="en-US" sz="800" i="1" dirty="0">
                 <a:solidFill>
                   <a:srgbClr val="6B7280"/>
                 </a:solidFill>
@@ -13671,19 +13671,19 @@
                 <a:ea typeface="Calibri" pitchFamily="34" charset="-122"/>
                 <a:cs typeface="Calibri" pitchFamily="34" charset="-120"/>
               </a:rPr>
-              <a:t>Based entirely on publicly available information.</a:t>
+              <a:t>Produced with the assistance of MIA, an AI-powered research tool.</a:t>
             </a:r>
-            <a:endParaRPr lang="en-US" sz="900" dirty="0"/>
+            <a:endParaRPr lang="en-US" sz="800" dirty="0"/>
           </a:p>
           <a:p>
             <a:pPr indent="0" marL="0">
               <a:lnSpc>
-                <a:spcPct val="130000"/>
+                <a:spcPct val="135000"/>
               </a:lnSpc>
               <a:buNone/>
             </a:pPr>
             <a:r>
-              <a:rPr lang="en-US" sz="900" i="1" dirty="0">
+              <a:rPr lang="en-US" sz="800" i="1" dirty="0">
                 <a:solidFill>
                   <a:srgbClr val="6B7280"/>
                 </a:solidFill>
@@ -13691,9 +13691,49 @@
                 <a:ea typeface="Calibri" pitchFamily="34" charset="-122"/>
                 <a:cs typeface="Calibri" pitchFamily="34" charset="-120"/>
               </a:rPr>
-              <a:t>No internal BMO data was used.</a:t>
+              <a:t>Not investment, financial, or professional advice. Based entirely on</a:t>
             </a:r>
-            <a:endParaRPr lang="en-US" sz="900" dirty="0"/>
+            <a:endParaRPr lang="en-US" sz="800" dirty="0"/>
+          </a:p>
+          <a:p>
+            <a:pPr indent="0" marL="0">
+              <a:lnSpc>
+                <a:spcPct val="135000"/>
+              </a:lnSpc>
+              <a:buNone/>
+            </a:pPr>
+            <a:r>
+              <a:rPr lang="en-US" sz="800" i="1" dirty="0">
+                <a:solidFill>
+                  <a:srgbClr val="6B7280"/>
+                </a:solidFill>
+                <a:latin typeface="Calibri" pitchFamily="34" charset="0"/>
+                <a:ea typeface="Calibri" pitchFamily="34" charset="-122"/>
+                <a:cs typeface="Calibri" pitchFamily="34" charset="-120"/>
+              </a:rPr>
+              <a:t>publicly available information — sources and methodology provided</a:t>
+            </a:r>
+            <a:endParaRPr lang="en-US" sz="800" dirty="0"/>
+          </a:p>
+          <a:p>
+            <a:pPr indent="0" marL="0">
+              <a:lnSpc>
+                <a:spcPct val="135000"/>
+              </a:lnSpc>
+              <a:buNone/>
+            </a:pPr>
+            <a:r>
+              <a:rPr lang="en-US" sz="800" i="1" dirty="0">
+                <a:solidFill>
+                  <a:srgbClr val="6B7280"/>
+                </a:solidFill>
+                <a:latin typeface="Calibri" pitchFamily="34" charset="0"/>
+                <a:ea typeface="Calibri" pitchFamily="34" charset="-122"/>
+                <a:cs typeface="Calibri" pitchFamily="34" charset="-120"/>
+              </a:rPr>
+              <a:t>for independent verification.</a:t>
+            </a:r>
+            <a:endParaRPr lang="en-US" sz="800" dirty="0"/>
           </a:p>
         </p:txBody>
       </p:sp>

</xml_diff>